<commit_message>
Expand presentation narrative and add LocalFind web prototype.
Story-driven slides with embedded product mockup; interactive
platform.html for search, filters, and business detail views.

Co-authored-by: Cursor <cursoragent@cursor.com>
</commit_message>
<xml_diff>
--- a/final/presentation/IMT542_Final_Project.pptx
+++ b/final/presentation/IMT542_Final_Project.pptx
@@ -16,6 +16,7 @@
     <p:sldId id="264" r:id="rId15"/>
     <p:sldId id="265" r:id="rId16"/>
     <p:sldId id="266" r:id="rId17"/>
+    <p:sldId id="267" r:id="rId18"/>
   </p:sldIdLst>
   <p:sldSz cx="9144000" cy="6858000" type="screen4x3"/>
   <p:notesSz cx="6858000" cy="9144000"/>
@@ -3121,14 +3122,14 @@
           <a:lstStyle/>
           <a:p>
             <a:pPr>
-              <a:defRPr sz="3000" b="1">
+              <a:defRPr sz="3200" b="1">
                 <a:solidFill>
                   <a:srgbClr val="4B2E83"/>
                 </a:solidFill>
               </a:defRPr>
             </a:pPr>
             <a:r>
-              <a:t>Neighborhood Small Business Platform</a:t>
+              <a:t>LocalFind</a:t>
             </a:r>
           </a:p>
         </p:txBody>
@@ -3141,8 +3142,8 @@
         </p:nvSpPr>
         <p:spPr>
           <a:xfrm>
-            <a:off x="457200" y="1325880"/>
-            <a:ext cx="8229600" cy="4754880"/>
+            <a:off x="457200" y="1280160"/>
+            <a:ext cx="8229600" cy="4846320"/>
           </a:xfrm>
           <a:prstGeom prst="rect">
             <a:avLst/>
@@ -3157,42 +3158,42 @@
           <a:p>
             <a:pPr>
               <a:spcAft>
-                <a:spcPts val="600"/>
+                <a:spcPts val="800"/>
               </a:spcAft>
-              <a:defRPr sz="1800"/>
-            </a:pPr>
-            <a:r>
-              <a:t>IMT 542 Final Project — Portable Information Structures</a:t>
+              <a:defRPr sz="1900"/>
+            </a:pPr>
+            <a:r>
+              <a:t>Helping Seattle residents discover and support independent neighborhood businesses.</a:t>
             </a:r>
           </a:p>
           <a:p>
             <a:pPr>
               <a:spcAft>
-                <a:spcPts val="600"/>
+                <a:spcPts val="800"/>
               </a:spcAft>
-              <a:defRPr sz="1800"/>
-            </a:pPr>
-            <a:r>
-              <a:t>Sneha Reddy | Spring 2026</a:t>
-            </a:r>
+              <a:defRPr sz="1900"/>
+            </a:pPr>
           </a:p>
           <a:p>
             <a:pPr>
               <a:spcAft>
-                <a:spcPts val="600"/>
+                <a:spcPts val="800"/>
               </a:spcAft>
-              <a:defRPr sz="1800"/>
-            </a:pPr>
+              <a:defRPr sz="1900"/>
+            </a:pPr>
+            <a:r>
+              <a:t>Sneha Reddy | IMT 542 | Spring 2026</a:t>
+            </a:r>
           </a:p>
           <a:p>
             <a:pPr>
               <a:spcAft>
-                <a:spcPts val="600"/>
+                <a:spcPts val="800"/>
               </a:spcAft>
-              <a:defRPr sz="1800"/>
-            </a:pPr>
-            <a:r>
-              <a:t>GitHub: github.com/Sneha-8/IMT-542/tree/main/final</a:t>
+              <a:defRPr sz="1900"/>
+            </a:pPr>
+            <a:r>
+              <a:t>github.com/Sneha-8/IMT-542</a:t>
             </a:r>
           </a:p>
         </p:txBody>
@@ -3238,14 +3239,14 @@
           <a:lstStyle/>
           <a:p>
             <a:pPr>
-              <a:defRPr sz="3000" b="1">
+              <a:defRPr sz="3200" b="1">
                 <a:solidFill>
                   <a:srgbClr val="4B2E83"/>
                 </a:solidFill>
               </a:defRPr>
             </a:pPr>
             <a:r>
-              <a:t>Security and Ethics</a:t>
+              <a:t>Under the hood</a:t>
             </a:r>
           </a:p>
         </p:txBody>
@@ -3258,8 +3259,8 @@
         </p:nvSpPr>
         <p:spPr>
           <a:xfrm>
-            <a:off x="457200" y="1325880"/>
-            <a:ext cx="8229600" cy="4754880"/>
+            <a:off x="457200" y="1280160"/>
+            <a:ext cx="8229600" cy="4846320"/>
           </a:xfrm>
           <a:prstGeom prst="rect">
             <a:avLst/>
@@ -3274,53 +3275,31 @@
           <a:p>
             <a:pPr>
               <a:spcAft>
-                <a:spcPts val="600"/>
+                <a:spcPts val="800"/>
               </a:spcAft>
-              <a:defRPr sz="1800"/>
-            </a:pPr>
-            <a:r>
-              <a:t>Bearer token unlocks email/phone (SBP_API_TOKEN)</a:t>
+              <a:defRPr sz="1900"/>
+            </a:pPr>
+            <a:r>
+              <a:t>Flask API | MongoDB/Mongita | Python normalizer | pytest + JSON Schema</a:t>
             </a:r>
           </a:p>
           <a:p>
             <a:pPr>
               <a:spcAft>
-                <a:spcPts val="600"/>
+                <a:spcPts val="800"/>
               </a:spcAft>
-              <a:defRPr sz="1800"/>
-            </a:pPr>
-            <a:r>
-              <a:t>Public responses strip restricted contact fields</a:t>
-            </a:r>
+              <a:defRPr sz="1900"/>
+            </a:pPr>
           </a:p>
           <a:p>
             <a:pPr>
               <a:spcAft>
-                <a:spcPts val="600"/>
+                <a:spcPts val="800"/>
               </a:spcAft>
-              <a:defRPr sz="1800"/>
-            </a:pPr>
-            <a:r>
-              <a:t>No secrets in repo; ethics doc in final/docs/06_Ethics_and_Limitations.md</a:t>
-            </a:r>
-          </a:p>
-          <a:p>
-            <a:pPr>
-              <a:spcAft>
-                <a:spcPts val="600"/>
-              </a:spcAft>
-              <a:defRPr sz="1800"/>
-            </a:pPr>
-          </a:p>
-          <a:p>
-            <a:pPr>
-              <a:spcAft>
-                <a:spcPts val="600"/>
-              </a:spcAft>
-              <a:defRPr sz="1800"/>
-            </a:pPr>
-            <a:r>
-              <a:t>Aligns with G9 test plan</a:t>
+              <a:defRPr sz="1900"/>
+            </a:pPr>
+            <a:r>
+              <a:t>Demo: six Seattle businesses. Live demo via ngrok during Q&amp;A.</a:t>
             </a:r>
           </a:p>
         </p:txBody>
@@ -3366,14 +3345,14 @@
           <a:lstStyle/>
           <a:p>
             <a:pPr>
-              <a:defRPr sz="3000" b="1">
+              <a:defRPr sz="3200" b="1">
                 <a:solidFill>
                   <a:srgbClr val="4B2E83"/>
                 </a:solidFill>
               </a:defRPr>
             </a:pPr>
             <a:r>
-              <a:t>Thank You / Questions</a:t>
+              <a:t>What comes next</a:t>
             </a:r>
           </a:p>
         </p:txBody>
@@ -3386,8 +3365,8 @@
         </p:nvSpPr>
         <p:spPr>
           <a:xfrm>
-            <a:off x="457200" y="1325880"/>
-            <a:ext cx="8229600" cy="4754880"/>
+            <a:off x="457200" y="1280160"/>
+            <a:ext cx="8229600" cy="4846320"/>
           </a:xfrm>
           <a:prstGeom prst="rect">
             <a:avLst/>
@@ -3402,50 +3381,159 @@
           <a:p>
             <a:pPr>
               <a:spcAft>
-                <a:spcPts val="600"/>
+                <a:spcPts val="800"/>
               </a:spcAft>
-              <a:defRPr sz="1800"/>
-            </a:pPr>
-            <a:r>
-              <a:t>Repository: github.com/Sneha-8/IMT-542</a:t>
+              <a:defRPr sz="1900"/>
+            </a:pPr>
+            <a:r>
+              <a:t>Live Yelp ingestion with caching.</a:t>
             </a:r>
           </a:p>
           <a:p>
             <a:pPr>
               <a:spcAft>
-                <a:spcPts val="600"/>
+                <a:spcPts val="800"/>
               </a:spcAft>
-              <a:defRPr sz="1800"/>
-            </a:pPr>
-            <a:r>
-              <a:t>Documentation: final/docs/</a:t>
+              <a:defRPr sz="1900"/>
+            </a:pPr>
+            <a:r>
+              <a:t>Public deployment of LocalFind.</a:t>
             </a:r>
           </a:p>
           <a:p>
             <a:pPr>
               <a:spcAft>
-                <a:spcPts val="600"/>
+                <a:spcPts val="800"/>
               </a:spcAft>
-              <a:defRPr sz="1800"/>
-            </a:pPr>
-            <a:r>
-              <a:t>Presentation HTML: final/presentation/index.html</a:t>
+              <a:defRPr sz="1900"/>
+            </a:pPr>
+            <a:r>
+              <a:t>Partnerships with neighborhood associations.</a:t>
             </a:r>
           </a:p>
           <a:p>
             <a:pPr>
               <a:spcAft>
-                <a:spcPts val="600"/>
+                <a:spcPts val="800"/>
               </a:spcAft>
-              <a:defRPr sz="1800"/>
-            </a:pPr>
-          </a:p>
+              <a:defRPr sz="1900"/>
+            </a:pPr>
+            <a:r>
+              <a:t>Feeds for maps and civic newsletters.</a:t>
+            </a:r>
+          </a:p>
+        </p:txBody>
+      </p:sp>
+    </p:spTree>
+  </p:cSld>
+  <p:clrMapOvr>
+    <a:masterClrMapping/>
+  </p:clrMapOvr>
+</p:sld>
+</file>
+
+<file path=ppt/slides/slide12.xml><?xml version="1.0" encoding="utf-8"?>
+<p:sld xmlns:a="http://schemas.openxmlformats.org/drawingml/2006/main" xmlns:p="http://schemas.openxmlformats.org/presentationml/2006/main" xmlns:r="http://schemas.openxmlformats.org/officeDocument/2006/relationships">
+  <p:cSld>
+    <p:spTree>
+      <p:nvGrpSpPr>
+        <p:cNvPr id="1" name=""/>
+        <p:cNvGrpSpPr/>
+        <p:nvPr/>
+      </p:nvGrpSpPr>
+      <p:grpSpPr/>
+      <p:sp>
+        <p:nvSpPr>
+          <p:cNvPr id="2" name="TextBox 1"/>
+          <p:cNvSpPr txBox="1"/>
+          <p:nvPr/>
+        </p:nvSpPr>
+        <p:spPr>
+          <a:xfrm>
+            <a:off x="457200" y="320040"/>
+            <a:ext cx="8229600" cy="914400"/>
+          </a:xfrm>
+          <a:prstGeom prst="rect">
+            <a:avLst/>
+          </a:prstGeom>
+          <a:noFill/>
+        </p:spPr>
+        <p:txBody>
+          <a:bodyPr wrap="none">
+            <a:spAutoFit/>
+          </a:bodyPr>
+          <a:lstStyle/>
+          <a:p>
+            <a:pPr>
+              <a:defRPr sz="3200" b="1">
+                <a:solidFill>
+                  <a:srgbClr val="4B2E83"/>
+                </a:solidFill>
+              </a:defRPr>
+            </a:pPr>
+            <a:r>
+              <a:t>Thank you</a:t>
+            </a:r>
+          </a:p>
+        </p:txBody>
+      </p:sp>
+      <p:sp>
+        <p:nvSpPr>
+          <p:cNvPr id="3" name="TextBox 2"/>
+          <p:cNvSpPr txBox="1"/>
+          <p:nvPr/>
+        </p:nvSpPr>
+        <p:spPr>
+          <a:xfrm>
+            <a:off x="457200" y="1280160"/>
+            <a:ext cx="8229600" cy="4846320"/>
+          </a:xfrm>
+          <a:prstGeom prst="rect">
+            <a:avLst/>
+          </a:prstGeom>
+          <a:noFill/>
+        </p:spPr>
+        <p:txBody>
+          <a:bodyPr wrap="square">
+            <a:spAutoFit/>
+          </a:bodyPr>
+          <a:lstStyle/>
           <a:p>
             <a:pPr>
               <a:spcAft>
-                <a:spcPts val="600"/>
+                <a:spcPts val="800"/>
               </a:spcAft>
-              <a:defRPr sz="1800"/>
+              <a:defRPr sz="1900"/>
+            </a:pPr>
+            <a:r>
+              <a:t>LocalFind — portable neighborhood business information.</a:t>
+            </a:r>
+          </a:p>
+          <a:p>
+            <a:pPr>
+              <a:spcAft>
+                <a:spcPts val="800"/>
+              </a:spcAft>
+              <a:defRPr sz="1900"/>
+            </a:pPr>
+          </a:p>
+          <a:p>
+            <a:pPr>
+              <a:spcAft>
+                <a:spcPts val="800"/>
+              </a:spcAft>
+              <a:defRPr sz="1900"/>
+            </a:pPr>
+            <a:r>
+              <a:t>github.com/Sneha-8/IMT-542/tree/main/final</a:t>
+            </a:r>
+          </a:p>
+          <a:p>
+            <a:pPr>
+              <a:spcAft>
+                <a:spcPts val="800"/>
+              </a:spcAft>
+              <a:defRPr sz="1900"/>
             </a:pPr>
             <a:r>
               <a:t>Questions?</a:t>
@@ -3494,14 +3582,14 @@
           <a:lstStyle/>
           <a:p>
             <a:pPr>
-              <a:defRPr sz="3000" b="1">
+              <a:defRPr sz="3200" b="1">
                 <a:solidFill>
                   <a:srgbClr val="4B2E83"/>
                 </a:solidFill>
               </a:defRPr>
             </a:pPr>
             <a:r>
-              <a:t>1. Information Story</a:t>
+              <a:t>Meet Alex</a:t>
             </a:r>
           </a:p>
         </p:txBody>
@@ -3514,8 +3602,8 @@
         </p:nvSpPr>
         <p:spPr>
           <a:xfrm>
-            <a:off x="457200" y="1325880"/>
-            <a:ext cx="8229600" cy="4754880"/>
+            <a:off x="457200" y="1280160"/>
+            <a:ext cx="8229600" cy="4846320"/>
           </a:xfrm>
           <a:prstGeom prst="rect">
             <a:avLst/>
@@ -3530,69 +3618,31 @@
           <a:p>
             <a:pPr>
               <a:spcAft>
-                <a:spcPts val="600"/>
+                <a:spcPts val="800"/>
               </a:spcAft>
-              <a:defRPr sz="1800"/>
-            </a:pPr>
-            <a:r>
-              <a:t>User: Seattle resident who wants to discover and support local shops</a:t>
+              <a:defRPr sz="1900"/>
+            </a:pPr>
+            <a:r>
+              <a:t>Alex lives in Capitol Hill and wants coffee from a local shop with vegan options and Wi-Fi. They open Yelp, scroll past ads, check Instagram, and often give up.</a:t>
             </a:r>
           </a:p>
           <a:p>
             <a:pPr>
               <a:spcAft>
-                <a:spcPts val="600"/>
+                <a:spcPts val="800"/>
               </a:spcAft>
-              <a:defRPr sz="1800"/>
+              <a:defRPr sz="1900"/>
             </a:pPr>
           </a:p>
           <a:p>
             <a:pPr>
               <a:spcAft>
-                <a:spcPts val="600"/>
+                <a:spcPts val="800"/>
               </a:spcAft>
-              <a:defRPr sz="1800"/>
-            </a:pPr>
-            <a:r>
-              <a:t>Problem: Business information is scattered across Yelp, HTML directories, and social media — not portable for apps or civic tools</a:t>
-            </a:r>
-          </a:p>
-          <a:p>
-            <a:pPr>
-              <a:spcAft>
-                <a:spcPts val="600"/>
-              </a:spcAft>
-              <a:defRPr sz="1800"/>
-            </a:pPr>
-          </a:p>
-          <a:p>
-            <a:pPr>
-              <a:spcAft>
-                <a:spcPts val="600"/>
-              </a:spcAft>
-              <a:defRPr sz="1800"/>
-            </a:pPr>
-            <a:r>
-              <a:t>Outcome: One machine-readable JSON feed with provenance and quality metrics</a:t>
-            </a:r>
-          </a:p>
-          <a:p>
-            <a:pPr>
-              <a:spcAft>
-                <a:spcPts val="600"/>
-              </a:spcAft>
-              <a:defRPr sz="1800"/>
-            </a:pPr>
-          </a:p>
-          <a:p>
-            <a:pPr>
-              <a:spcAft>
-                <a:spcPts val="600"/>
-              </a:spcAft>
-              <a:defRPr sz="1800"/>
-            </a:pPr>
-            <a:r>
-              <a:t>Insight: Visualize listings + analyze relationships (stats, open-now)</a:t>
+              <a:defRPr sz="1900"/>
+            </a:pPr>
+            <a:r>
+              <a:t>The information exists — it is scattered and locked in apps that were not built for this decision.</a:t>
             </a:r>
           </a:p>
         </p:txBody>
@@ -3638,14 +3688,14 @@
           <a:lstStyle/>
           <a:p>
             <a:pPr>
-              <a:defRPr sz="3000" b="1">
+              <a:defRPr sz="3200" b="1">
                 <a:solidFill>
                   <a:srgbClr val="4B2E83"/>
                 </a:solidFill>
               </a:defRPr>
             </a:pPr>
             <a:r>
-              <a:t>Users and Requirements</a:t>
+              <a:t>Why local discovery matters</a:t>
             </a:r>
           </a:p>
         </p:txBody>
@@ -3658,8 +3708,8 @@
         </p:nvSpPr>
         <p:spPr>
           <a:xfrm>
-            <a:off x="457200" y="1325880"/>
-            <a:ext cx="8229600" cy="4754880"/>
+            <a:off x="457200" y="1280160"/>
+            <a:ext cx="8229600" cy="4846320"/>
           </a:xfrm>
           <a:prstGeom prst="rect">
             <a:avLst/>
@@ -3674,64 +3724,34 @@
           <a:p>
             <a:pPr>
               <a:spcAft>
-                <a:spcPts val="600"/>
+                <a:spcPts val="800"/>
               </a:spcAft>
-              <a:defRPr sz="1800"/>
-            </a:pPr>
-            <a:r>
-              <a:t>Residents — search by neighborhood, tags, open now</a:t>
+              <a:defRPr sz="1900"/>
+            </a:pPr>
+            <a:r>
+              <a:t>Local spending strengthens neighborhood economies.</a:t>
             </a:r>
           </a:p>
           <a:p>
             <a:pPr>
               <a:spcAft>
-                <a:spcPts val="600"/>
+                <a:spcPts val="800"/>
               </a:spcAft>
-              <a:defRPr sz="1800"/>
-            </a:pPr>
-            <a:r>
-              <a:t>Owners — stable public listing; restricted contact fields</a:t>
+              <a:defRPr sz="1900"/>
+            </a:pPr>
+            <a:r>
+              <a:t>Small shops lack chain-level SEO and ad budgets.</a:t>
             </a:r>
           </a:p>
           <a:p>
             <a:pPr>
               <a:spcAft>
-                <a:spcPts val="600"/>
+                <a:spcPts val="800"/>
               </a:spcAft>
-              <a:defRPr sz="1800"/>
-            </a:pPr>
-            <a:r>
-              <a:t>Developers — JSON Schema contract + provenance</a:t>
-            </a:r>
-          </a:p>
-          <a:p>
-            <a:pPr>
-              <a:spcAft>
-                <a:spcPts val="600"/>
-              </a:spcAft>
-              <a:defRPr sz="1800"/>
-            </a:pPr>
-          </a:p>
-          <a:p>
-            <a:pPr>
-              <a:spcAft>
-                <a:spcPts val="600"/>
-              </a:spcAft>
-              <a:defRPr sz="1800"/>
-            </a:pPr>
-            <a:r>
-              <a:t>In scope: SBP v1.0 API, FAIR metadata, NoSQL, auth-gated contact</a:t>
-            </a:r>
-          </a:p>
-          <a:p>
-            <a:pPr>
-              <a:spcAft>
-                <a:spcPts val="600"/>
-              </a:spcAft>
-              <a:defRPr sz="1800"/>
-            </a:pPr>
-            <a:r>
-              <a:t>Out of scope: payments, Yelp production key in repo, native mobile app</a:t>
+              <a:defRPr sz="1900"/>
+            </a:pPr>
+            <a:r>
+              <a:t>Civic tools and newsletters need machine-readable listings, not HTML tables.</a:t>
             </a:r>
           </a:p>
         </p:txBody>
@@ -3777,14 +3797,14 @@
           <a:lstStyle/>
           <a:p>
             <a:pPr>
-              <a:defRPr sz="3000" b="1">
+              <a:defRPr sz="3200" b="1">
                 <a:solidFill>
                   <a:srgbClr val="4B2E83"/>
                 </a:solidFill>
               </a:defRPr>
             </a:pPr>
             <a:r>
-              <a:t>2. Existing Structures and FAIR</a:t>
+              <a:t>Where information lives today</a:t>
             </a:r>
           </a:p>
         </p:txBody>
@@ -3797,8 +3817,8 @@
         </p:nvSpPr>
         <p:spPr>
           <a:xfrm>
-            <a:off x="457200" y="1325880"/>
-            <a:ext cx="8229600" cy="4754880"/>
+            <a:off x="457200" y="1280160"/>
+            <a:ext cx="8229600" cy="4846320"/>
           </a:xfrm>
           <a:prstGeom prst="rect">
             <a:avLst/>
@@ -3813,75 +3833,53 @@
           <a:p>
             <a:pPr>
               <a:spcAft>
-                <a:spcPts val="600"/>
+                <a:spcPts val="800"/>
               </a:spcAft>
-              <a:defRPr sz="1800"/>
-            </a:pPr>
-            <a:r>
-              <a:t>Sources analyzed:</a:t>
+              <a:defRPr sz="1900"/>
+            </a:pPr>
+            <a:r>
+              <a:t>Yelp and Google (proprietary, ad-driven)</a:t>
             </a:r>
           </a:p>
           <a:p>
             <a:pPr>
               <a:spcAft>
-                <a:spcPts val="600"/>
+                <a:spcPts val="800"/>
               </a:spcAft>
-              <a:defRPr sz="1800"/>
-            </a:pPr>
-            <a:r>
-              <a:t>  - Yelp Fusion API (nested vendor JSON, license limits)</a:t>
+              <a:defRPr sz="1900"/>
+            </a:pPr>
+            <a:r>
+              <a:t>Chamber HTML directories (no stable IDs)</a:t>
             </a:r>
           </a:p>
           <a:p>
             <a:pPr>
               <a:spcAft>
-                <a:spcPts val="600"/>
+                <a:spcPts val="800"/>
               </a:spcAft>
-              <a:defRPr sz="1800"/>
-            </a:pPr>
-            <a:r>
-              <a:t>  - HTML neighborhood directories (no stable IDs)</a:t>
+              <a:defRPr sz="1900"/>
+            </a:pPr>
+            <a:r>
+              <a:t>Social posts and owner sites (unstructured)</a:t>
             </a:r>
           </a:p>
           <a:p>
             <a:pPr>
               <a:spcAft>
-                <a:spcPts val="600"/>
+                <a:spcPts val="800"/>
               </a:spcAft>
-              <a:defRPr sz="1800"/>
-            </a:pPr>
-            <a:r>
-              <a:t>  - I7 static JSON (no provenance or schema version)</a:t>
-            </a:r>
+              <a:defRPr sz="1900"/>
+            </a:pPr>
           </a:p>
           <a:p>
             <a:pPr>
               <a:spcAft>
-                <a:spcPts val="600"/>
+                <a:spcPts val="800"/>
               </a:spcAft>
-              <a:defRPr sz="1800"/>
-            </a:pPr>
-          </a:p>
-          <a:p>
-            <a:pPr>
-              <a:spcAft>
-                <a:spcPts val="600"/>
-              </a:spcAft>
-              <a:defRPr sz="1800"/>
-            </a:pPr>
-            <a:r>
-              <a:t>FAIR gaps: weak reusability, inconsistent access, no completeness metrics</a:t>
-            </a:r>
-          </a:p>
-          <a:p>
-            <a:pPr>
-              <a:spcAft>
-                <a:spcPts val="600"/>
-              </a:spcAft>
-              <a:defRPr sz="1800"/>
-            </a:pPr>
-            <a:r>
-              <a:t>SBP adds: stable IDs, HTTPS REST, JSON Schema, provenance.license</a:t>
+              <a:defRPr sz="1900"/>
+            </a:pPr>
+            <a:r>
+              <a:t>Problems: cannot combine open-now + tags + neighborhood in one query; no provenance; owner contact mixed with public data.</a:t>
             </a:r>
           </a:p>
         </p:txBody>
@@ -3927,14 +3925,14 @@
           <a:lstStyle/>
           <a:p>
             <a:pPr>
-              <a:defRPr sz="3000" b="1">
+              <a:defRPr sz="3200" b="1">
                 <a:solidFill>
                   <a:srgbClr val="4B2E83"/>
                 </a:solidFill>
               </a:defRPr>
             </a:pPr>
             <a:r>
-              <a:t>3. Structure Improvements</a:t>
+              <a:t>The journey we designed</a:t>
             </a:r>
           </a:p>
         </p:txBody>
@@ -3947,8 +3945,8 @@
         </p:nvSpPr>
         <p:spPr>
           <a:xfrm>
-            <a:off x="457200" y="1325880"/>
-            <a:ext cx="8229600" cy="4754880"/>
+            <a:off x="457200" y="1280160"/>
+            <a:ext cx="8229600" cy="4846320"/>
           </a:xfrm>
           <a:prstGeom prst="rect">
             <a:avLst/>
@@ -3963,56 +3961,31 @@
           <a:p>
             <a:pPr>
               <a:spcAft>
-                <a:spcPts val="600"/>
+                <a:spcPts val="800"/>
               </a:spcAft>
-              <a:defRPr sz="1800"/>
-            </a:pPr>
-            <a:r>
-              <a:t>At least 4 dimensions changed:</a:t>
+              <a:defRPr sz="1900"/>
+            </a:pPr>
+            <a:r>
+              <a:t>Sources -&gt; normalize to one schema -&gt; document database -&gt; REST API -&gt; LocalFind UI</a:t>
             </a:r>
           </a:p>
           <a:p>
             <a:pPr>
               <a:spcAft>
-                <a:spcPts val="600"/>
+                <a:spcPts val="800"/>
               </a:spcAft>
-              <a:defRPr sz="1800"/>
-            </a:pPr>
-            <a:r>
-              <a:t>  Information — quality_flags, completeness_score</a:t>
-            </a:r>
+              <a:defRPr sz="1900"/>
+            </a:pPr>
           </a:p>
           <a:p>
             <a:pPr>
               <a:spcAft>
-                <a:spcPts val="600"/>
+                <a:spcPts val="800"/>
               </a:spcAft>
-              <a:defRPr sz="1800"/>
-            </a:pPr>
-            <a:r>
-              <a:t>  Structure — SBP envelope + flattened LocalBusiness fields</a:t>
-            </a:r>
-          </a:p>
-          <a:p>
-            <a:pPr>
-              <a:spcAft>
-                <a:spcPts val="600"/>
-              </a:spcAft>
-              <a:defRPr sz="1800"/>
-            </a:pPr>
-            <a:r>
-              <a:t>  Format — schema_version 1.0 + sbp_schema_v1.json</a:t>
-            </a:r>
-          </a:p>
-          <a:p>
-            <a:pPr>
-              <a:spcAft>
-                <a:spcPts val="600"/>
-              </a:spcAft>
-              <a:defRPr sz="1800"/>
-            </a:pPr>
-            <a:r>
-              <a:t>  Access — REST /businesses/search vs file-in-memory (I7)</a:t>
+              <a:defRPr sz="1900"/>
+            </a:pPr>
+            <a:r>
+              <a:t>Same facts can power a website, map layer, newsletter, or assistant without re-scraping.</a:t>
             </a:r>
           </a:p>
         </p:txBody>
@@ -4058,14 +4031,14 @@
           <a:lstStyle/>
           <a:p>
             <a:pPr>
-              <a:defRPr sz="3000" b="1">
+              <a:defRPr sz="3200" b="1">
                 <a:solidFill>
                   <a:srgbClr val="4B2E83"/>
                 </a:solidFill>
               </a:defRPr>
             </a:pPr>
             <a:r>
-              <a:t>New Portable Structure</a:t>
+              <a:t>The LocalFind experience</a:t>
             </a:r>
           </a:p>
         </p:txBody>
@@ -4078,8 +4051,8 @@
         </p:nvSpPr>
         <p:spPr>
           <a:xfrm>
-            <a:off x="457200" y="1325880"/>
-            <a:ext cx="8229600" cy="4754880"/>
+            <a:off x="457200" y="1280160"/>
+            <a:ext cx="8229600" cy="4846320"/>
           </a:xfrm>
           <a:prstGeom prst="rect">
             <a:avLst/>
@@ -4094,50 +4067,53 @@
           <a:p>
             <a:pPr>
               <a:spcAft>
-                <a:spcPts val="600"/>
+                <a:spcPts val="800"/>
               </a:spcAft>
-              <a:defRPr sz="1800"/>
-            </a:pPr>
-            <a:r>
-              <a:t>Top-level: schema_version, provenance, query_summary, businesses[]</a:t>
+              <a:defRPr sz="1900"/>
+            </a:pPr>
+            <a:r>
+              <a:t>Search by keyword, neighborhood, and tags.</a:t>
             </a:r>
           </a:p>
           <a:p>
             <a:pPr>
               <a:spcAft>
-                <a:spcPts val="600"/>
+                <a:spcPts val="800"/>
               </a:spcAft>
-              <a:defRPr sz="1800"/>
-            </a:pPr>
+              <a:defRPr sz="1900"/>
+            </a:pPr>
+            <a:r>
+              <a:t>See ratings, hours, open-now status, and popular items.</a:t>
+            </a:r>
           </a:p>
           <a:p>
             <a:pPr>
               <a:spcAft>
-                <a:spcPts val="600"/>
+                <a:spcPts val="800"/>
               </a:spcAft>
-              <a:defRPr sz="1800"/>
-            </a:pPr>
-            <a:r>
-              <a:t>Per business: id, name, categories, rating, location, contact, tags, hours, products, quality_flags</a:t>
+              <a:defRPr sz="1900"/>
+            </a:pPr>
+            <a:r>
+              <a:t>Business detail with website, directions, and provenance footer.</a:t>
             </a:r>
           </a:p>
           <a:p>
             <a:pPr>
               <a:spcAft>
-                <a:spcPts val="600"/>
+                <a:spcPts val="800"/>
               </a:spcAft>
-              <a:defRPr sz="1800"/>
+              <a:defRPr sz="1900"/>
             </a:pPr>
           </a:p>
           <a:p>
             <a:pPr>
               <a:spcAft>
-                <a:spcPts val="600"/>
+                <a:spcPts val="800"/>
               </a:spcAft>
-              <a:defRPr sz="1800"/>
-            </a:pPr>
-            <a:r>
-              <a:t>Normalizer: small_businesses.json -&gt; SBP record (normalizer.py)</a:t>
+              <a:defRPr sz="1900"/>
+            </a:pPr>
+            <a:r>
+              <a:t>See live prototype: final/web/platform.html (open in browser during demo)</a:t>
             </a:r>
           </a:p>
         </p:txBody>
@@ -4183,14 +4159,14 @@
           <a:lstStyle/>
           <a:p>
             <a:pPr>
-              <a:defRPr sz="3000" b="1">
+              <a:defRPr sz="3200" b="1">
                 <a:solidFill>
                   <a:srgbClr val="4B2E83"/>
                 </a:solidFill>
               </a:defRPr>
             </a:pPr>
             <a:r>
-              <a:t>4. Functional System</a:t>
+              <a:t>Portable structure — what changed</a:t>
             </a:r>
           </a:p>
         </p:txBody>
@@ -4203,8 +4179,8 @@
         </p:nvSpPr>
         <p:spPr>
           <a:xfrm>
-            <a:off x="457200" y="1325880"/>
-            <a:ext cx="8229600" cy="4754880"/>
+            <a:off x="457200" y="1280160"/>
+            <a:ext cx="8229600" cy="4846320"/>
           </a:xfrm>
           <a:prstGeom prst="rect">
             <a:avLst/>
@@ -4219,83 +4195,34 @@
           <a:p>
             <a:pPr>
               <a:spcAft>
-                <a:spcPts val="600"/>
+                <a:spcPts val="800"/>
               </a:spcAft>
-              <a:defRPr sz="1800"/>
-            </a:pPr>
-            <a:r>
-              <a:t>Stack: JSON source -&gt; seed_db.py -&gt; MongoDB/Mongita -&gt; Flask API</a:t>
+              <a:defRPr sz="1900"/>
+            </a:pPr>
+            <a:r>
+              <a:t>Envelope: schema version, provenance, completeness on every response.</a:t>
             </a:r>
           </a:p>
           <a:p>
             <a:pPr>
               <a:spcAft>
-                <a:spcPts val="600"/>
+                <a:spcPts val="800"/>
               </a:spcAft>
-              <a:defRPr sz="1800"/>
-            </a:pPr>
+              <a:defRPr sz="1900"/>
+            </a:pPr>
+            <a:r>
+              <a:t>Records: split addresses, E.164 phones, tags, hours, quality flags.</a:t>
+            </a:r>
           </a:p>
           <a:p>
             <a:pPr>
               <a:spcAft>
-                <a:spcPts val="600"/>
+                <a:spcPts val="800"/>
               </a:spcAft>
-              <a:defRPr sz="1800"/>
-            </a:pPr>
-            <a:r>
-              <a:t>Run locally:</a:t>
-            </a:r>
-          </a:p>
-          <a:p>
-            <a:pPr>
-              <a:spcAft>
-                <a:spcPts val="600"/>
-              </a:spcAft>
-              <a:defRPr sz="1800"/>
-            </a:pPr>
-            <a:r>
-              <a:t>  export USE_MONGITA=true &amp;&amp; python seed_db.py</a:t>
-            </a:r>
-          </a:p>
-          <a:p>
-            <a:pPr>
-              <a:spcAft>
-                <a:spcPts val="600"/>
-              </a:spcAft>
-              <a:defRPr sz="1800"/>
-            </a:pPr>
-            <a:r>
-              <a:t>  flask --app app run -p 5002</a:t>
-            </a:r>
-          </a:p>
-          <a:p>
-            <a:pPr>
-              <a:spcAft>
-                <a:spcPts val="600"/>
-              </a:spcAft>
-              <a:defRPr sz="1800"/>
-            </a:pPr>
-            <a:r>
-              <a:t>  ngrok http 5002  (submit HTTPS URL to Canvas)</a:t>
-            </a:r>
-          </a:p>
-          <a:p>
-            <a:pPr>
-              <a:spcAft>
-                <a:spcPts val="600"/>
-              </a:spcAft>
-              <a:defRPr sz="1800"/>
-            </a:pPr>
-          </a:p>
-          <a:p>
-            <a:pPr>
-              <a:spcAft>
-                <a:spcPts val="600"/>
-              </a:spcAft>
-              <a:defRPr sz="1800"/>
-            </a:pPr>
-            <a:r>
-              <a:t>Demo client: python access_api.py</a:t>
+              <a:defRPr sz="1900"/>
+            </a:pPr>
+            <a:r>
+              <a:t>Access: HTTPS search API instead of a static JSON file only developers can read.</a:t>
             </a:r>
           </a:p>
         </p:txBody>
@@ -4341,14 +4268,14 @@
           <a:lstStyle/>
           <a:p>
             <a:pPr>
-              <a:defRPr sz="3000" b="1">
+              <a:defRPr sz="3200" b="1">
                 <a:solidFill>
                   <a:srgbClr val="4B2E83"/>
                 </a:solidFill>
               </a:defRPr>
             </a:pPr>
             <a:r>
-              <a:t>Live Demo Endpoints</a:t>
+              <a:t>Trust and privacy</a:t>
             </a:r>
           </a:p>
         </p:txBody>
@@ -4361,8 +4288,8 @@
         </p:nvSpPr>
         <p:spPr>
           <a:xfrm>
-            <a:off x="457200" y="1325880"/>
-            <a:ext cx="8229600" cy="4754880"/>
+            <a:off x="457200" y="1280160"/>
+            <a:ext cx="8229600" cy="4846320"/>
           </a:xfrm>
           <a:prstGeom prst="rect">
             <a:avLst/>
@@ -4377,75 +4304,34 @@
           <a:p>
             <a:pPr>
               <a:spcAft>
-                <a:spcPts val="600"/>
+                <a:spcPts val="800"/>
               </a:spcAft>
-              <a:defRPr sz="1800"/>
-            </a:pPr>
-            <a:r>
-              <a:t>GET /health</a:t>
+              <a:defRPr sz="1900"/>
+            </a:pPr>
+            <a:r>
+              <a:t>Provenance and license on every payload.</a:t>
             </a:r>
           </a:p>
           <a:p>
             <a:pPr>
               <a:spcAft>
-                <a:spcPts val="600"/>
+                <a:spcPts val="800"/>
               </a:spcAft>
-              <a:defRPr sz="1800"/>
-            </a:pPr>
-            <a:r>
-              <a:t>GET /schema</a:t>
+              <a:defRPr sz="1900"/>
+            </a:pPr>
+            <a:r>
+              <a:t>Quality flags so consumers know what is missing.</a:t>
             </a:r>
           </a:p>
           <a:p>
             <a:pPr>
               <a:spcAft>
-                <a:spcPts val="600"/>
+                <a:spcPts val="800"/>
               </a:spcAft>
-              <a:defRPr sz="1800"/>
-            </a:pPr>
-            <a:r>
-              <a:t>GET /businesses/search?term=coffee&amp;location=Capitol Hill</a:t>
-            </a:r>
-          </a:p>
-          <a:p>
-            <a:pPr>
-              <a:spcAft>
-                <a:spcPts val="600"/>
-              </a:spcAft>
-              <a:defRPr sz="1800"/>
-            </a:pPr>
-            <a:r>
-              <a:t>GET /businesses/sb-001</a:t>
-            </a:r>
-          </a:p>
-          <a:p>
-            <a:pPr>
-              <a:spcAft>
-                <a:spcPts val="600"/>
-              </a:spcAft>
-              <a:defRPr sz="1800"/>
-            </a:pPr>
-            <a:r>
-              <a:t>GET /stats  |  GET /open-now</a:t>
-            </a:r>
-          </a:p>
-          <a:p>
-            <a:pPr>
-              <a:spcAft>
-                <a:spcPts val="600"/>
-              </a:spcAft>
-              <a:defRPr sz="1800"/>
-            </a:pPr>
-          </a:p>
-          <a:p>
-            <a:pPr>
-              <a:spcAft>
-                <a:spcPts val="600"/>
-              </a:spcAft>
-              <a:defRPr sz="1800"/>
-            </a:pPr>
-            <a:r>
-              <a:t>HTML slides: final/presentation/index.html?api=&lt;ngrok-url&gt;</a:t>
+              <a:defRPr sz="1900"/>
+            </a:pPr>
+            <a:r>
+              <a:t>Public listings hide owner email/phone unless Bearer token authorizes access.</a:t>
             </a:r>
           </a:p>
         </p:txBody>
@@ -4491,14 +4377,14 @@
           <a:lstStyle/>
           <a:p>
             <a:pPr>
-              <a:defRPr sz="3000" b="1">
+              <a:defRPr sz="3200" b="1">
                 <a:solidFill>
                   <a:srgbClr val="4B2E83"/>
                 </a:solidFill>
               </a:defRPr>
             </a:pPr>
             <a:r>
-              <a:t>Quality and Performance</a:t>
+              <a:t>How we got here</a:t>
             </a:r>
           </a:p>
         </p:txBody>
@@ -4511,8 +4397,8 @@
         </p:nvSpPr>
         <p:spPr>
           <a:xfrm>
-            <a:off x="457200" y="1325880"/>
-            <a:ext cx="8229600" cy="4754880"/>
+            <a:off x="457200" y="1280160"/>
+            <a:ext cx="8229600" cy="4846320"/>
           </a:xfrm>
           <a:prstGeom prst="rect">
             <a:avLst/>
@@ -4527,53 +4413,53 @@
           <a:p>
             <a:pPr>
               <a:spcAft>
-                <a:spcPts val="600"/>
+                <a:spcPts val="800"/>
               </a:spcAft>
-              <a:defRPr sz="1800"/>
-            </a:pPr>
-            <a:r>
-              <a:t>Desired: completeness &gt;= 0.85, schema validates 100%</a:t>
+              <a:defRPr sz="1900"/>
+            </a:pPr>
+            <a:r>
+              <a:t>Started with Flask + JSON file.</a:t>
             </a:r>
           </a:p>
           <a:p>
             <a:pPr>
               <a:spcAft>
-                <a:spcPts val="600"/>
+                <a:spcPts val="800"/>
               </a:spcAft>
-              <a:defRPr sz="1800"/>
-            </a:pPr>
-            <a:r>
-              <a:t>Observed: ~0.92 completeness on demo set; 9 pytest tests pass</a:t>
+              <a:defRPr sz="1900"/>
+            </a:pPr>
+            <a:r>
+              <a:t>Added MongoDB and aggregation endpoints.</a:t>
             </a:r>
           </a:p>
           <a:p>
             <a:pPr>
               <a:spcAft>
-                <a:spcPts val="600"/>
+                <a:spcPts val="800"/>
               </a:spcAft>
-              <a:defRPr sz="1800"/>
-            </a:pPr>
-            <a:r>
-              <a:t>Latency: warm search &lt; 50 ms local</a:t>
+              <a:defRPr sz="1900"/>
+            </a:pPr>
+            <a:r>
+              <a:t>Shipped schema v1.0, normalizer, tests, and this UI prototype.</a:t>
             </a:r>
           </a:p>
           <a:p>
             <a:pPr>
               <a:spcAft>
-                <a:spcPts val="600"/>
+                <a:spcPts val="800"/>
               </a:spcAft>
-              <a:defRPr sz="1800"/>
+              <a:defRPr sz="1900"/>
             </a:pPr>
           </a:p>
           <a:p>
             <a:pPr>
               <a:spcAft>
-                <a:spcPts val="600"/>
+                <a:spcPts val="800"/>
               </a:spcAft>
-              <a:defRPr sz="1800"/>
-            </a:pPr>
-            <a:r>
-              <a:t>Remediation: Yelp live adapter, UptimeRobot, Locust load tests (G9)</a:t>
+              <a:defRPr sz="1900"/>
+            </a:pPr>
+            <a:r>
+              <a:t>Production path: Yelp Fusion feeds the same normalizer.</a:t>
             </a:r>
           </a:p>
         </p:txBody>

</xml_diff>

<commit_message>
Complete LocalFind final submission with live Yelp and OSM integration.
Add SBP v1.0 API, LocalFind UI with ZIP filtering, rubric docs, v4 presentation,
cache populate scripts, and expanded tests for final project delivery.

Co-authored-by: Cursor <cursoragent@cursor.com>
</commit_message>
<xml_diff>
--- a/final/presentation/IMT542_Final_Project.pptx
+++ b/final/presentation/IMT542_Final_Project.pptx
@@ -13,10 +13,6 @@
     <p:sldId id="261" r:id="rId12"/>
     <p:sldId id="262" r:id="rId13"/>
     <p:sldId id="263" r:id="rId14"/>
-    <p:sldId id="264" r:id="rId15"/>
-    <p:sldId id="265" r:id="rId16"/>
-    <p:sldId id="266" r:id="rId17"/>
-    <p:sldId id="267" r:id="rId18"/>
   </p:sldIdLst>
   <p:sldSz cx="9144000" cy="6858000" type="screen4x3"/>
   <p:notesSz cx="6858000" cy="9144000"/>
@@ -3107,8 +3103,8 @@
         </p:nvSpPr>
         <p:spPr>
           <a:xfrm>
-            <a:off x="457200" y="320040"/>
-            <a:ext cx="8229600" cy="914400"/>
+            <a:off x="411480" y="274320"/>
+            <a:ext cx="8321040" cy="868680"/>
           </a:xfrm>
           <a:prstGeom prst="rect">
             <a:avLst/>
@@ -3122,7 +3118,7 @@
           <a:lstStyle/>
           <a:p>
             <a:pPr>
-              <a:defRPr sz="3200" b="1">
+              <a:defRPr sz="2800" b="1">
                 <a:solidFill>
                   <a:srgbClr val="4B2E83"/>
                 </a:solidFill>
@@ -3142,8 +3138,8 @@
         </p:nvSpPr>
         <p:spPr>
           <a:xfrm>
-            <a:off x="457200" y="1280160"/>
-            <a:ext cx="8229600" cy="4846320"/>
+            <a:off x="411480" y="1143000"/>
+            <a:ext cx="8321040" cy="5029200"/>
           </a:xfrm>
           <a:prstGeom prst="rect">
             <a:avLst/>
@@ -3158,385 +3154,23 @@
           <a:p>
             <a:pPr>
               <a:spcAft>
-                <a:spcPts val="800"/>
+                <a:spcPts val="600"/>
               </a:spcAft>
-              <a:defRPr sz="1900"/>
-            </a:pPr>
-            <a:r>
-              <a:t>Helping Seattle residents discover and support independent neighborhood businesses.</a:t>
+              <a:defRPr sz="1700"/>
+            </a:pPr>
+            <a:r>
+              <a:t>One place to discover small businesses in your neighborhood.</a:t>
             </a:r>
           </a:p>
           <a:p>
             <a:pPr>
               <a:spcAft>
-                <a:spcPts val="800"/>
+                <a:spcPts val="600"/>
               </a:spcAft>
-              <a:defRPr sz="1900"/>
-            </a:pPr>
-          </a:p>
-          <a:p>
-            <a:pPr>
-              <a:spcAft>
-                <a:spcPts val="800"/>
-              </a:spcAft>
-              <a:defRPr sz="1900"/>
-            </a:pPr>
-            <a:r>
-              <a:t>Sneha Reddy | IMT 542 | Spring 2026</a:t>
-            </a:r>
-          </a:p>
-          <a:p>
-            <a:pPr>
-              <a:spcAft>
-                <a:spcPts val="800"/>
-              </a:spcAft>
-              <a:defRPr sz="1900"/>
-            </a:pPr>
-            <a:r>
-              <a:t>github.com/Sneha-8/IMT-542</a:t>
-            </a:r>
-          </a:p>
-        </p:txBody>
-      </p:sp>
-    </p:spTree>
-  </p:cSld>
-  <p:clrMapOvr>
-    <a:masterClrMapping/>
-  </p:clrMapOvr>
-</p:sld>
-</file>
-
-<file path=ppt/slides/slide10.xml><?xml version="1.0" encoding="utf-8"?>
-<p:sld xmlns:a="http://schemas.openxmlformats.org/drawingml/2006/main" xmlns:p="http://schemas.openxmlformats.org/presentationml/2006/main" xmlns:r="http://schemas.openxmlformats.org/officeDocument/2006/relationships">
-  <p:cSld>
-    <p:spTree>
-      <p:nvGrpSpPr>
-        <p:cNvPr id="1" name=""/>
-        <p:cNvGrpSpPr/>
-        <p:nvPr/>
-      </p:nvGrpSpPr>
-      <p:grpSpPr/>
-      <p:sp>
-        <p:nvSpPr>
-          <p:cNvPr id="2" name="TextBox 1"/>
-          <p:cNvSpPr txBox="1"/>
-          <p:nvPr/>
-        </p:nvSpPr>
-        <p:spPr>
-          <a:xfrm>
-            <a:off x="457200" y="320040"/>
-            <a:ext cx="8229600" cy="914400"/>
-          </a:xfrm>
-          <a:prstGeom prst="rect">
-            <a:avLst/>
-          </a:prstGeom>
-          <a:noFill/>
-        </p:spPr>
-        <p:txBody>
-          <a:bodyPr wrap="none">
-            <a:spAutoFit/>
-          </a:bodyPr>
-          <a:lstStyle/>
-          <a:p>
-            <a:pPr>
-              <a:defRPr sz="3200" b="1">
-                <a:solidFill>
-                  <a:srgbClr val="4B2E83"/>
-                </a:solidFill>
-              </a:defRPr>
-            </a:pPr>
-            <a:r>
-              <a:t>Under the hood</a:t>
-            </a:r>
-          </a:p>
-        </p:txBody>
-      </p:sp>
-      <p:sp>
-        <p:nvSpPr>
-          <p:cNvPr id="3" name="TextBox 2"/>
-          <p:cNvSpPr txBox="1"/>
-          <p:nvPr/>
-        </p:nvSpPr>
-        <p:spPr>
-          <a:xfrm>
-            <a:off x="457200" y="1280160"/>
-            <a:ext cx="8229600" cy="4846320"/>
-          </a:xfrm>
-          <a:prstGeom prst="rect">
-            <a:avLst/>
-          </a:prstGeom>
-          <a:noFill/>
-        </p:spPr>
-        <p:txBody>
-          <a:bodyPr wrap="square">
-            <a:spAutoFit/>
-          </a:bodyPr>
-          <a:lstStyle/>
-          <a:p>
-            <a:pPr>
-              <a:spcAft>
-                <a:spcPts val="800"/>
-              </a:spcAft>
-              <a:defRPr sz="1900"/>
-            </a:pPr>
-            <a:r>
-              <a:t>Flask API | MongoDB/Mongita | Python normalizer | pytest + JSON Schema</a:t>
-            </a:r>
-          </a:p>
-          <a:p>
-            <a:pPr>
-              <a:spcAft>
-                <a:spcPts val="800"/>
-              </a:spcAft>
-              <a:defRPr sz="1900"/>
-            </a:pPr>
-          </a:p>
-          <a:p>
-            <a:pPr>
-              <a:spcAft>
-                <a:spcPts val="800"/>
-              </a:spcAft>
-              <a:defRPr sz="1900"/>
-            </a:pPr>
-            <a:r>
-              <a:t>Demo: six Seattle businesses. Live demo via ngrok during Q&amp;A.</a:t>
-            </a:r>
-          </a:p>
-        </p:txBody>
-      </p:sp>
-    </p:spTree>
-  </p:cSld>
-  <p:clrMapOvr>
-    <a:masterClrMapping/>
-  </p:clrMapOvr>
-</p:sld>
-</file>
-
-<file path=ppt/slides/slide11.xml><?xml version="1.0" encoding="utf-8"?>
-<p:sld xmlns:a="http://schemas.openxmlformats.org/drawingml/2006/main" xmlns:p="http://schemas.openxmlformats.org/presentationml/2006/main" xmlns:r="http://schemas.openxmlformats.org/officeDocument/2006/relationships">
-  <p:cSld>
-    <p:spTree>
-      <p:nvGrpSpPr>
-        <p:cNvPr id="1" name=""/>
-        <p:cNvGrpSpPr/>
-        <p:nvPr/>
-      </p:nvGrpSpPr>
-      <p:grpSpPr/>
-      <p:sp>
-        <p:nvSpPr>
-          <p:cNvPr id="2" name="TextBox 1"/>
-          <p:cNvSpPr txBox="1"/>
-          <p:nvPr/>
-        </p:nvSpPr>
-        <p:spPr>
-          <a:xfrm>
-            <a:off x="457200" y="320040"/>
-            <a:ext cx="8229600" cy="914400"/>
-          </a:xfrm>
-          <a:prstGeom prst="rect">
-            <a:avLst/>
-          </a:prstGeom>
-          <a:noFill/>
-        </p:spPr>
-        <p:txBody>
-          <a:bodyPr wrap="none">
-            <a:spAutoFit/>
-          </a:bodyPr>
-          <a:lstStyle/>
-          <a:p>
-            <a:pPr>
-              <a:defRPr sz="3200" b="1">
-                <a:solidFill>
-                  <a:srgbClr val="4B2E83"/>
-                </a:solidFill>
-              </a:defRPr>
-            </a:pPr>
-            <a:r>
-              <a:t>What comes next</a:t>
-            </a:r>
-          </a:p>
-        </p:txBody>
-      </p:sp>
-      <p:sp>
-        <p:nvSpPr>
-          <p:cNvPr id="3" name="TextBox 2"/>
-          <p:cNvSpPr txBox="1"/>
-          <p:nvPr/>
-        </p:nvSpPr>
-        <p:spPr>
-          <a:xfrm>
-            <a:off x="457200" y="1280160"/>
-            <a:ext cx="8229600" cy="4846320"/>
-          </a:xfrm>
-          <a:prstGeom prst="rect">
-            <a:avLst/>
-          </a:prstGeom>
-          <a:noFill/>
-        </p:spPr>
-        <p:txBody>
-          <a:bodyPr wrap="square">
-            <a:spAutoFit/>
-          </a:bodyPr>
-          <a:lstStyle/>
-          <a:p>
-            <a:pPr>
-              <a:spcAft>
-                <a:spcPts val="800"/>
-              </a:spcAft>
-              <a:defRPr sz="1900"/>
-            </a:pPr>
-            <a:r>
-              <a:t>Live Yelp ingestion with caching.</a:t>
-            </a:r>
-          </a:p>
-          <a:p>
-            <a:pPr>
-              <a:spcAft>
-                <a:spcPts val="800"/>
-              </a:spcAft>
-              <a:defRPr sz="1900"/>
-            </a:pPr>
-            <a:r>
-              <a:t>Public deployment of LocalFind.</a:t>
-            </a:r>
-          </a:p>
-          <a:p>
-            <a:pPr>
-              <a:spcAft>
-                <a:spcPts val="800"/>
-              </a:spcAft>
-              <a:defRPr sz="1900"/>
-            </a:pPr>
-            <a:r>
-              <a:t>Partnerships with neighborhood associations.</a:t>
-            </a:r>
-          </a:p>
-          <a:p>
-            <a:pPr>
-              <a:spcAft>
-                <a:spcPts val="800"/>
-              </a:spcAft>
-              <a:defRPr sz="1900"/>
-            </a:pPr>
-            <a:r>
-              <a:t>Feeds for maps and civic newsletters.</a:t>
-            </a:r>
-          </a:p>
-        </p:txBody>
-      </p:sp>
-    </p:spTree>
-  </p:cSld>
-  <p:clrMapOvr>
-    <a:masterClrMapping/>
-  </p:clrMapOvr>
-</p:sld>
-</file>
-
-<file path=ppt/slides/slide12.xml><?xml version="1.0" encoding="utf-8"?>
-<p:sld xmlns:a="http://schemas.openxmlformats.org/drawingml/2006/main" xmlns:p="http://schemas.openxmlformats.org/presentationml/2006/main" xmlns:r="http://schemas.openxmlformats.org/officeDocument/2006/relationships">
-  <p:cSld>
-    <p:spTree>
-      <p:nvGrpSpPr>
-        <p:cNvPr id="1" name=""/>
-        <p:cNvGrpSpPr/>
-        <p:nvPr/>
-      </p:nvGrpSpPr>
-      <p:grpSpPr/>
-      <p:sp>
-        <p:nvSpPr>
-          <p:cNvPr id="2" name="TextBox 1"/>
-          <p:cNvSpPr txBox="1"/>
-          <p:nvPr/>
-        </p:nvSpPr>
-        <p:spPr>
-          <a:xfrm>
-            <a:off x="457200" y="320040"/>
-            <a:ext cx="8229600" cy="914400"/>
-          </a:xfrm>
-          <a:prstGeom prst="rect">
-            <a:avLst/>
-          </a:prstGeom>
-          <a:noFill/>
-        </p:spPr>
-        <p:txBody>
-          <a:bodyPr wrap="none">
-            <a:spAutoFit/>
-          </a:bodyPr>
-          <a:lstStyle/>
-          <a:p>
-            <a:pPr>
-              <a:defRPr sz="3200" b="1">
-                <a:solidFill>
-                  <a:srgbClr val="4B2E83"/>
-                </a:solidFill>
-              </a:defRPr>
-            </a:pPr>
-            <a:r>
-              <a:t>Thank you</a:t>
-            </a:r>
-          </a:p>
-        </p:txBody>
-      </p:sp>
-      <p:sp>
-        <p:nvSpPr>
-          <p:cNvPr id="3" name="TextBox 2"/>
-          <p:cNvSpPr txBox="1"/>
-          <p:nvPr/>
-        </p:nvSpPr>
-        <p:spPr>
-          <a:xfrm>
-            <a:off x="457200" y="1280160"/>
-            <a:ext cx="8229600" cy="4846320"/>
-          </a:xfrm>
-          <a:prstGeom prst="rect">
-            <a:avLst/>
-          </a:prstGeom>
-          <a:noFill/>
-        </p:spPr>
-        <p:txBody>
-          <a:bodyPr wrap="square">
-            <a:spAutoFit/>
-          </a:bodyPr>
-          <a:lstStyle/>
-          <a:p>
-            <a:pPr>
-              <a:spcAft>
-                <a:spcPts val="800"/>
-              </a:spcAft>
-              <a:defRPr sz="1900"/>
-            </a:pPr>
-            <a:r>
-              <a:t>LocalFind — portable neighborhood business information.</a:t>
-            </a:r>
-          </a:p>
-          <a:p>
-            <a:pPr>
-              <a:spcAft>
-                <a:spcPts val="800"/>
-              </a:spcAft>
-              <a:defRPr sz="1900"/>
-            </a:pPr>
-          </a:p>
-          <a:p>
-            <a:pPr>
-              <a:spcAft>
-                <a:spcPts val="800"/>
-              </a:spcAft>
-              <a:defRPr sz="1900"/>
-            </a:pPr>
-            <a:r>
-              <a:t>github.com/Sneha-8/IMT-542/tree/main/final</a:t>
-            </a:r>
-          </a:p>
-          <a:p>
-            <a:pPr>
-              <a:spcAft>
-                <a:spcPts val="800"/>
-              </a:spcAft>
-              <a:defRPr sz="1900"/>
-            </a:pPr>
-            <a:r>
-              <a:t>Questions?</a:t>
+              <a:defRPr sz="1700"/>
+            </a:pPr>
+            <a:r>
+              <a:t>Sneha Reddy | IMT 542 | github.com/Sneha-8/IMT-542</a:t>
             </a:r>
           </a:p>
         </p:txBody>
@@ -3567,8 +3201,8 @@
         </p:nvSpPr>
         <p:spPr>
           <a:xfrm>
-            <a:off x="457200" y="320040"/>
-            <a:ext cx="8229600" cy="914400"/>
+            <a:off x="411480" y="274320"/>
+            <a:ext cx="8321040" cy="868680"/>
           </a:xfrm>
           <a:prstGeom prst="rect">
             <a:avLst/>
@@ -3582,14 +3216,14 @@
           <a:lstStyle/>
           <a:p>
             <a:pPr>
-              <a:defRPr sz="3200" b="1">
+              <a:defRPr sz="2800" b="1">
                 <a:solidFill>
                   <a:srgbClr val="4B2E83"/>
                 </a:solidFill>
               </a:defRPr>
             </a:pPr>
             <a:r>
-              <a:t>Meet Alex</a:t>
+              <a:t>Information story — who and why</a:t>
             </a:r>
           </a:p>
         </p:txBody>
@@ -3602,8 +3236,8 @@
         </p:nvSpPr>
         <p:spPr>
           <a:xfrm>
-            <a:off x="457200" y="1280160"/>
-            <a:ext cx="8229600" cy="4846320"/>
+            <a:off x="411480" y="1143000"/>
+            <a:ext cx="8321040" cy="5029200"/>
           </a:xfrm>
           <a:prstGeom prst="rect">
             <a:avLst/>
@@ -3618,31 +3252,105 @@
           <a:p>
             <a:pPr>
               <a:spcAft>
-                <a:spcPts val="800"/>
+                <a:spcPts val="600"/>
               </a:spcAft>
-              <a:defRPr sz="1900"/>
-            </a:pPr>
-            <a:r>
-              <a:t>Alex lives in Capitol Hill and wants coffee from a local shop with vegan options and Wi-Fi. They open Yelp, scroll past ads, check Instagram, and often give up.</a:t>
+              <a:defRPr sz="1700"/>
+            </a:pPr>
+            <a:r>
+              <a:t>Story: Community members find small businesses around them (cafes, salons, shops).</a:t>
             </a:r>
           </a:p>
           <a:p>
             <a:pPr>
               <a:spcAft>
-                <a:spcPts val="800"/>
+                <a:spcPts val="600"/>
               </a:spcAft>
-              <a:defRPr sz="1900"/>
+              <a:defRPr sz="1700"/>
             </a:pPr>
           </a:p>
           <a:p>
             <a:pPr>
               <a:spcAft>
-                <a:spcPts val="800"/>
+                <a:spcPts val="600"/>
               </a:spcAft>
-              <a:defRPr sz="1900"/>
-            </a:pPr>
-            <a:r>
-              <a:t>The information exists — it is scattered and locked in apps that were not built for this decision.</a:t>
+              <a:defRPr sz="1700"/>
+            </a:pPr>
+            <a:r>
+              <a:t>Who benefits:</a:t>
+            </a:r>
+          </a:p>
+          <a:p>
+            <a:pPr>
+              <a:spcAft>
+                <a:spcPts val="600"/>
+              </a:spcAft>
+              <a:defRPr sz="1700"/>
+            </a:pPr>
+            <a:r>
+              <a:t>  Residents — discover shops they did not know existed nearby</a:t>
+            </a:r>
+          </a:p>
+          <a:p>
+            <a:pPr>
+              <a:spcAft>
+                <a:spcPts val="600"/>
+              </a:spcAft>
+              <a:defRPr sz="1700"/>
+            </a:pPr>
+            <a:r>
+              <a:t>  Owners — more discoverability in one combined feed</a:t>
+            </a:r>
+          </a:p>
+          <a:p>
+            <a:pPr>
+              <a:spcAft>
+                <a:spcPts val="600"/>
+              </a:spcAft>
+              <a:defRPr sz="1700"/>
+            </a:pPr>
+          </a:p>
+          <a:p>
+            <a:pPr>
+              <a:spcAft>
+                <a:spcPts val="600"/>
+              </a:spcAft>
+              <a:defRPr sz="1700"/>
+            </a:pPr>
+            <a:r>
+              <a:t>Why it matters:</a:t>
+            </a:r>
+          </a:p>
+          <a:p>
+            <a:pPr>
+              <a:spcAft>
+                <a:spcPts val="600"/>
+              </a:spcAft>
+              <a:defRPr sz="1700"/>
+            </a:pPr>
+            <a:r>
+              <a:t>  Local shops are hard to see next to big chains</a:t>
+            </a:r>
+          </a:p>
+          <a:p>
+            <a:pPr>
+              <a:spcAft>
+                <a:spcPts val="600"/>
+              </a:spcAft>
+              <a:defRPr sz="1700"/>
+            </a:pPr>
+            <a:r>
+              <a:t>  Supporting nearby business keeps money in the community</a:t>
+            </a:r>
+          </a:p>
+          <a:p>
+            <a:pPr>
+              <a:spcAft>
+                <a:spcPts val="600"/>
+              </a:spcAft>
+              <a:defRPr sz="1700"/>
+            </a:pPr>
+            <a:r>
+              <a:t>  One search beats checking Yelp, Google, and social separately</a:t>
             </a:r>
           </a:p>
         </p:txBody>
@@ -3673,8 +3381,8 @@
         </p:nvSpPr>
         <p:spPr>
           <a:xfrm>
-            <a:off x="457200" y="320040"/>
-            <a:ext cx="8229600" cy="914400"/>
+            <a:off x="411480" y="274320"/>
+            <a:ext cx="8321040" cy="868680"/>
           </a:xfrm>
           <a:prstGeom prst="rect">
             <a:avLst/>
@@ -3688,14 +3396,14 @@
           <a:lstStyle/>
           <a:p>
             <a:pPr>
-              <a:defRPr sz="3200" b="1">
+              <a:defRPr sz="2800" b="1">
                 <a:solidFill>
                   <a:srgbClr val="4B2E83"/>
                 </a:solidFill>
               </a:defRPr>
             </a:pPr>
             <a:r>
-              <a:t>Why local discovery matters</a:t>
+              <a:t>Current problems</a:t>
             </a:r>
           </a:p>
         </p:txBody>
@@ -3708,8 +3416,8 @@
         </p:nvSpPr>
         <p:spPr>
           <a:xfrm>
-            <a:off x="457200" y="1280160"/>
-            <a:ext cx="8229600" cy="4846320"/>
+            <a:off x="411480" y="1143000"/>
+            <a:ext cx="8321040" cy="5029200"/>
           </a:xfrm>
           <a:prstGeom prst="rect">
             <a:avLst/>
@@ -3724,34 +3432,64 @@
           <a:p>
             <a:pPr>
               <a:spcAft>
-                <a:spcPts val="800"/>
+                <a:spcPts val="600"/>
               </a:spcAft>
-              <a:defRPr sz="1900"/>
-            </a:pPr>
-            <a:r>
-              <a:t>Local spending strengthens neighborhood economies.</a:t>
+              <a:defRPr sz="1700"/>
+            </a:pPr>
+            <a:r>
+              <a:t>Most people do not know how many small businesses exist near them.</a:t>
             </a:r>
           </a:p>
           <a:p>
             <a:pPr>
               <a:spcAft>
-                <a:spcPts val="800"/>
+                <a:spcPts val="600"/>
               </a:spcAft>
-              <a:defRPr sz="1900"/>
-            </a:pPr>
-            <a:r>
-              <a:t>Small shops lack chain-level SEO and ad budgets.</a:t>
+              <a:defRPr sz="1700"/>
+            </a:pPr>
+            <a:r>
+              <a:t>There is no single way to answer what local shops are nearby.</a:t>
             </a:r>
           </a:p>
           <a:p>
             <a:pPr>
               <a:spcAft>
-                <a:spcPts val="800"/>
+                <a:spcPts val="600"/>
               </a:spcAft>
-              <a:defRPr sz="1900"/>
-            </a:pPr>
-            <a:r>
-              <a:t>Civic tools and newsletters need machine-readable listings, not HTML tables.</a:t>
+              <a:defRPr sz="1700"/>
+            </a:pPr>
+            <a:r>
+              <a:t>Information is split across Yelp, Google, Instagram, chamber sites, owner pages.</a:t>
+            </a:r>
+          </a:p>
+          <a:p>
+            <a:pPr>
+              <a:spcAft>
+                <a:spcPts val="600"/>
+              </a:spcAft>
+              <a:defRPr sz="1700"/>
+            </a:pPr>
+            <a:r>
+              <a:t>Each source uses different fields, ads, and rules — every search starts over.</a:t>
+            </a:r>
+          </a:p>
+          <a:p>
+            <a:pPr>
+              <a:spcAft>
+                <a:spcPts val="600"/>
+              </a:spcAft>
+              <a:defRPr sz="1700"/>
+            </a:pPr>
+          </a:p>
+          <a:p>
+            <a:pPr>
+              <a:spcAft>
+                <a:spcPts val="600"/>
+              </a:spcAft>
+              <a:defRPr sz="1700"/>
+            </a:pPr>
+            <a:r>
+              <a:t>The data exists. It is not combined in a form people can use.</a:t>
             </a:r>
           </a:p>
         </p:txBody>
@@ -3782,8 +3520,8 @@
         </p:nvSpPr>
         <p:spPr>
           <a:xfrm>
-            <a:off x="457200" y="320040"/>
-            <a:ext cx="8229600" cy="914400"/>
+            <a:off x="411480" y="274320"/>
+            <a:ext cx="8321040" cy="868680"/>
           </a:xfrm>
           <a:prstGeom prst="rect">
             <a:avLst/>
@@ -3797,14 +3535,14 @@
           <a:lstStyle/>
           <a:p>
             <a:pPr>
-              <a:defRPr sz="3200" b="1">
+              <a:defRPr sz="2800" b="1">
                 <a:solidFill>
                   <a:srgbClr val="4B2E83"/>
                 </a:solidFill>
               </a:defRPr>
             </a:pPr>
             <a:r>
-              <a:t>Where information lives today</a:t>
+              <a:t>FAIR assessment — Yelp + OpenStreetMap</a:t>
             </a:r>
           </a:p>
         </p:txBody>
@@ -3817,8 +3555,8 @@
         </p:nvSpPr>
         <p:spPr>
           <a:xfrm>
-            <a:off x="457200" y="1280160"/>
-            <a:ext cx="8229600" cy="4846320"/>
+            <a:off x="411480" y="1143000"/>
+            <a:ext cx="8321040" cy="5029200"/>
           </a:xfrm>
           <a:prstGeom prst="rect">
             <a:avLst/>
@@ -3833,53 +3571,75 @@
           <a:p>
             <a:pPr>
               <a:spcAft>
-                <a:spcPts val="800"/>
+                <a:spcPts val="600"/>
               </a:spcAft>
-              <a:defRPr sz="1900"/>
-            </a:pPr>
-            <a:r>
-              <a:t>Yelp and Google (proprietary, ad-driven)</a:t>
+              <a:defRPr sz="1700"/>
+            </a:pPr>
+            <a:r>
+              <a:t>                Yelp Fusion          OpenStreetMap</a:t>
             </a:r>
           </a:p>
           <a:p>
             <a:pPr>
               <a:spcAft>
-                <a:spcPts val="800"/>
+                <a:spcPts val="600"/>
               </a:spcAft>
-              <a:defRPr sz="1900"/>
-            </a:pPr>
-            <a:r>
-              <a:t>Chamber HTML directories (no stable IDs)</a:t>
+              <a:defRPr sz="1700"/>
+            </a:pPr>
+            <a:r>
+              <a:t>Findable         Partial              Partial</a:t>
             </a:r>
           </a:p>
           <a:p>
             <a:pPr>
               <a:spcAft>
-                <a:spcPts val="800"/>
+                <a:spcPts val="600"/>
               </a:spcAft>
-              <a:defRPr sz="1900"/>
-            </a:pPr>
-            <a:r>
-              <a:t>Social posts and owner sites (unstructured)</a:t>
+              <a:defRPr sz="1700"/>
+            </a:pPr>
+            <a:r>
+              <a:t>Accessible       Partial (API key)    Partial (throttle)</a:t>
             </a:r>
           </a:p>
           <a:p>
             <a:pPr>
               <a:spcAft>
-                <a:spcPts val="800"/>
+                <a:spcPts val="600"/>
               </a:spcAft>
-              <a:defRPr sz="1900"/>
-            </a:pPr>
+              <a:defRPr sz="1700"/>
+            </a:pPr>
+            <a:r>
+              <a:t>Interoperable    Low                  Partial (tags)</a:t>
+            </a:r>
           </a:p>
           <a:p>
             <a:pPr>
               <a:spcAft>
-                <a:spcPts val="800"/>
+                <a:spcPts val="600"/>
               </a:spcAft>
-              <a:defRPr sz="1900"/>
-            </a:pPr>
-            <a:r>
-              <a:t>Problems: cannot combine open-now + tags + neighborhood in one query; no provenance; owner contact mixed with public data.</a:t>
+              <a:defRPr sz="1700"/>
+            </a:pPr>
+            <a:r>
+              <a:t>Reusable         Low (display-only)   High (ODbL)</a:t>
+            </a:r>
+          </a:p>
+          <a:p>
+            <a:pPr>
+              <a:spcAft>
+                <a:spcPts val="600"/>
+              </a:spcAft>
+              <a:defRPr sz="1700"/>
+            </a:pPr>
+          </a:p>
+          <a:p>
+            <a:pPr>
+              <a:spcAft>
+                <a:spcPts val="600"/>
+              </a:spcAft>
+              <a:defRPr sz="1700"/>
+            </a:pPr>
+            <a:r>
+              <a:t>Yelp: ratings, photos, hours. OSM: open map data. Neither alone fits our story.</a:t>
             </a:r>
           </a:p>
         </p:txBody>
@@ -3910,8 +3670,8 @@
         </p:nvSpPr>
         <p:spPr>
           <a:xfrm>
-            <a:off x="457200" y="320040"/>
-            <a:ext cx="8229600" cy="914400"/>
+            <a:off x="411480" y="274320"/>
+            <a:ext cx="8321040" cy="868680"/>
           </a:xfrm>
           <a:prstGeom prst="rect">
             <a:avLst/>
@@ -3925,14 +3685,14 @@
           <a:lstStyle/>
           <a:p>
             <a:pPr>
-              <a:defRPr sz="3200" b="1">
+              <a:defRPr sz="2800" b="1">
                 <a:solidFill>
                   <a:srgbClr val="4B2E83"/>
                 </a:solidFill>
               </a:defRPr>
             </a:pPr>
             <a:r>
-              <a:t>The journey we designed</a:t>
+              <a:t>Our solution — SBP v1.0 + LocalFind</a:t>
             </a:r>
           </a:p>
         </p:txBody>
@@ -3945,8 +3705,8 @@
         </p:nvSpPr>
         <p:spPr>
           <a:xfrm>
-            <a:off x="457200" y="1280160"/>
-            <a:ext cx="8229600" cy="4846320"/>
+            <a:off x="411480" y="1143000"/>
+            <a:ext cx="8321040" cy="5029200"/>
           </a:xfrm>
           <a:prstGeom prst="rect">
             <a:avLst/>
@@ -3961,31 +3721,94 @@
           <a:p>
             <a:pPr>
               <a:spcAft>
-                <a:spcPts val="800"/>
+                <a:spcPts val="600"/>
               </a:spcAft>
-              <a:defRPr sz="1900"/>
-            </a:pPr>
-            <a:r>
-              <a:t>Sources -&gt; normalize to one schema -&gt; document database -&gt; REST API -&gt; LocalFind UI</a:t>
+              <a:defRPr sz="1700"/>
+            </a:pPr>
+            <a:r>
+              <a:t>Pipeline: Yelp + OSM -&gt; normalizer -&gt; cache -&gt; API -&gt; LocalFind UI</a:t>
             </a:r>
           </a:p>
           <a:p>
             <a:pPr>
               <a:spcAft>
-                <a:spcPts val="800"/>
+                <a:spcPts val="600"/>
               </a:spcAft>
-              <a:defRPr sz="1900"/>
+              <a:defRPr sz="1700"/>
             </a:pPr>
           </a:p>
           <a:p>
             <a:pPr>
               <a:spcAft>
-                <a:spcPts val="800"/>
+                <a:spcPts val="600"/>
               </a:spcAft>
-              <a:defRPr sz="1900"/>
-            </a:pPr>
-            <a:r>
-              <a:t>Same facts can power a website, map layer, newsletter, or assistant without re-scraping.</a:t>
+              <a:defRPr sz="1700"/>
+            </a:pPr>
+            <a:r>
+              <a:t>Design for FAIR gaps:</a:t>
+            </a:r>
+          </a:p>
+          <a:p>
+            <a:pPr>
+              <a:spcAft>
+                <a:spcPts val="600"/>
+              </a:spcAft>
+              <a:defRPr sz="1700"/>
+            </a:pPr>
+            <a:r>
+              <a:t>  Findable — stable id, schema_version</a:t>
+            </a:r>
+          </a:p>
+          <a:p>
+            <a:pPr>
+              <a:spcAft>
+                <a:spcPts val="600"/>
+              </a:spcAft>
+              <a:defRPr sz="1700"/>
+            </a:pPr>
+            <a:r>
+              <a:t>  Accessible — REST + web (ZIP, category, near me)</a:t>
+            </a:r>
+          </a:p>
+          <a:p>
+            <a:pPr>
+              <a:spcAft>
+                <a:spcPts val="600"/>
+              </a:spcAft>
+              <a:defRPr sz="1700"/>
+            </a:pPr>
+            <a:r>
+              <a:t>  Interoperable — one JSON shape for both sources</a:t>
+            </a:r>
+          </a:p>
+          <a:p>
+            <a:pPr>
+              <a:spcAft>
+                <a:spcPts val="600"/>
+              </a:spcAft>
+              <a:defRPr sz="1700"/>
+            </a:pPr>
+            <a:r>
+              <a:t>  Reusable — provenance + quality_flags on every response</a:t>
+            </a:r>
+          </a:p>
+          <a:p>
+            <a:pPr>
+              <a:spcAft>
+                <a:spcPts val="600"/>
+              </a:spcAft>
+              <a:defRPr sz="1700"/>
+            </a:pPr>
+          </a:p>
+          <a:p>
+            <a:pPr>
+              <a:spcAft>
+                <a:spcPts val="600"/>
+              </a:spcAft>
+              <a:defRPr sz="1700"/>
+            </a:pPr>
+            <a:r>
+              <a:t>Example: merged record with name, zip_code, hours, rating, yelp_url, osm_url</a:t>
             </a:r>
           </a:p>
         </p:txBody>
@@ -4016,8 +3839,8 @@
         </p:nvSpPr>
         <p:spPr>
           <a:xfrm>
-            <a:off x="457200" y="320040"/>
-            <a:ext cx="8229600" cy="914400"/>
+            <a:off x="411480" y="274320"/>
+            <a:ext cx="8321040" cy="868680"/>
           </a:xfrm>
           <a:prstGeom prst="rect">
             <a:avLst/>
@@ -4031,14 +3854,14 @@
           <a:lstStyle/>
           <a:p>
             <a:pPr>
-              <a:defRPr sz="3200" b="1">
+              <a:defRPr sz="2800" b="1">
                 <a:solidFill>
                   <a:srgbClr val="4B2E83"/>
                 </a:solidFill>
               </a:defRPr>
             </a:pPr>
             <a:r>
-              <a:t>The LocalFind experience</a:t>
+              <a:t>Quality, performance, security</a:t>
             </a:r>
           </a:p>
         </p:txBody>
@@ -4051,8 +3874,8 @@
         </p:nvSpPr>
         <p:spPr>
           <a:xfrm>
-            <a:off x="457200" y="1280160"/>
-            <a:ext cx="8229600" cy="4846320"/>
+            <a:off x="411480" y="1143000"/>
+            <a:ext cx="8321040" cy="5029200"/>
           </a:xfrm>
           <a:prstGeom prst="rect">
             <a:avLst/>
@@ -4067,53 +3890,45 @@
           <a:p>
             <a:pPr>
               <a:spcAft>
-                <a:spcPts val="800"/>
+                <a:spcPts val="600"/>
               </a:spcAft>
-              <a:defRPr sz="1900"/>
-            </a:pPr>
-            <a:r>
-              <a:t>Search by keyword, neighborhood, and tags.</a:t>
+              <a:defRPr sz="1700"/>
+            </a:pPr>
+            <a:r>
+              <a:t>Quality: JSON Schema; completeness_score; 12 pytest tests</a:t>
             </a:r>
           </a:p>
           <a:p>
             <a:pPr>
               <a:spcAft>
-                <a:spcPts val="800"/>
+                <a:spcPts val="600"/>
               </a:spcAft>
-              <a:defRPr sz="1900"/>
-            </a:pPr>
-            <a:r>
-              <a:t>See ratings, hours, open-now status, and popular items.</a:t>
+              <a:defRPr sz="1700"/>
+            </a:pPr>
+            <a:r>
+              <a:t>Performance: cached search ~20-100 ms; live refresh ~15-40 s</a:t>
             </a:r>
           </a:p>
           <a:p>
             <a:pPr>
               <a:spcAft>
-                <a:spcPts val="800"/>
+                <a:spcPts val="600"/>
               </a:spcAft>
-              <a:defRPr sz="1900"/>
-            </a:pPr>
-            <a:r>
-              <a:t>Business detail with website, directions, and provenance footer.</a:t>
+              <a:defRPr sz="1700"/>
+            </a:pPr>
+            <a:r>
+              <a:t>Security: public API hides phone/email; Bearer unlocks contact; keys in .env only</a:t>
             </a:r>
           </a:p>
           <a:p>
             <a:pPr>
               <a:spcAft>
-                <a:spcPts val="800"/>
+                <a:spcPts val="600"/>
               </a:spcAft>
-              <a:defRPr sz="1900"/>
-            </a:pPr>
-          </a:p>
-          <a:p>
-            <a:pPr>
-              <a:spcAft>
-                <a:spcPts val="800"/>
-              </a:spcAft>
-              <a:defRPr sz="1900"/>
-            </a:pPr>
-            <a:r>
-              <a:t>See live prototype: final/web/platform.html (open in browser during demo)</a:t>
+              <a:defRPr sz="1700"/>
+            </a:pPr>
+            <a:r>
+              <a:t>Tradeoffs: cache speed vs freshness; more metadata vs larger payloads</a:t>
             </a:r>
           </a:p>
         </p:txBody>
@@ -4144,8 +3959,8 @@
         </p:nvSpPr>
         <p:spPr>
           <a:xfrm>
-            <a:off x="457200" y="320040"/>
-            <a:ext cx="8229600" cy="914400"/>
+            <a:off x="411480" y="274320"/>
+            <a:ext cx="8321040" cy="868680"/>
           </a:xfrm>
           <a:prstGeom prst="rect">
             <a:avLst/>
@@ -4159,14 +3974,14 @@
           <a:lstStyle/>
           <a:p>
             <a:pPr>
-              <a:defRPr sz="3200" b="1">
+              <a:defRPr sz="2800" b="1">
                 <a:solidFill>
                   <a:srgbClr val="4B2E83"/>
                 </a:solidFill>
               </a:defRPr>
             </a:pPr>
             <a:r>
-              <a:t>Portable structure — what changed</a:t>
+              <a:t>Demo — LocalFind</a:t>
             </a:r>
           </a:p>
         </p:txBody>
@@ -4179,8 +3994,8 @@
         </p:nvSpPr>
         <p:spPr>
           <a:xfrm>
-            <a:off x="457200" y="1280160"/>
-            <a:ext cx="8229600" cy="4846320"/>
+            <a:off x="411480" y="1143000"/>
+            <a:ext cx="8321040" cy="5029200"/>
           </a:xfrm>
           <a:prstGeom prst="rect">
             <a:avLst/>
@@ -4195,34 +4010,34 @@
           <a:p>
             <a:pPr>
               <a:spcAft>
-                <a:spcPts val="800"/>
+                <a:spcPts val="600"/>
               </a:spcAft>
-              <a:defRPr sz="1900"/>
-            </a:pPr>
-            <a:r>
-              <a:t>Envelope: schema version, provenance, completeness on every response.</a:t>
+              <a:defRPr sz="1700"/>
+            </a:pPr>
+            <a:r>
+              <a:t>Search by category, ZIP, or near me.</a:t>
             </a:r>
           </a:p>
           <a:p>
             <a:pPr>
               <a:spcAft>
-                <a:spcPts val="800"/>
+                <a:spcPts val="600"/>
               </a:spcAft>
-              <a:defRPr sz="1900"/>
-            </a:pPr>
-            <a:r>
-              <a:t>Records: split addresses, E.164 phones, tags, hours, quality flags.</a:t>
+              <a:defRPr sz="1700"/>
+            </a:pPr>
+            <a:r>
+              <a:t>Open a listing for hours, ratings, directions.</a:t>
             </a:r>
           </a:p>
           <a:p>
             <a:pPr>
               <a:spcAft>
-                <a:spcPts val="800"/>
+                <a:spcPts val="600"/>
               </a:spcAft>
-              <a:defRPr sz="1900"/>
-            </a:pPr>
-            <a:r>
-              <a:t>Access: HTTPS search API instead of a static JSON file only developers can read.</a:t>
+              <a:defRPr sz="1700"/>
+            </a:pPr>
+            <a:r>
+              <a:t>http://127.0.0.1:8777/web/platform.html</a:t>
             </a:r>
           </a:p>
         </p:txBody>
@@ -4253,8 +4068,8 @@
         </p:nvSpPr>
         <p:spPr>
           <a:xfrm>
-            <a:off x="457200" y="320040"/>
-            <a:ext cx="8229600" cy="914400"/>
+            <a:off x="411480" y="274320"/>
+            <a:ext cx="8321040" cy="868680"/>
           </a:xfrm>
           <a:prstGeom prst="rect">
             <a:avLst/>
@@ -4268,14 +4083,14 @@
           <a:lstStyle/>
           <a:p>
             <a:pPr>
-              <a:defRPr sz="3200" b="1">
+              <a:defRPr sz="2800" b="1">
                 <a:solidFill>
                   <a:srgbClr val="4B2E83"/>
                 </a:solidFill>
               </a:defRPr>
             </a:pPr>
             <a:r>
-              <a:t>Trust and privacy</a:t>
+              <a:t>Thank you</a:t>
             </a:r>
           </a:p>
         </p:txBody>
@@ -4288,8 +4103,8 @@
         </p:nvSpPr>
         <p:spPr>
           <a:xfrm>
-            <a:off x="457200" y="1280160"/>
-            <a:ext cx="8229600" cy="4846320"/>
+            <a:off x="411480" y="1143000"/>
+            <a:ext cx="8321040" cy="5029200"/>
           </a:xfrm>
           <a:prstGeom prst="rect">
             <a:avLst/>
@@ -4304,162 +4119,34 @@
           <a:p>
             <a:pPr>
               <a:spcAft>
-                <a:spcPts val="800"/>
+                <a:spcPts val="600"/>
               </a:spcAft>
-              <a:defRPr sz="1900"/>
-            </a:pPr>
-            <a:r>
-              <a:t>Provenance and license on every payload.</a:t>
+              <a:defRPr sz="1700"/>
+            </a:pPr>
+            <a:r>
+              <a:t>LocalFind — discover local small businesses; more visibility for owners.</a:t>
             </a:r>
           </a:p>
           <a:p>
             <a:pPr>
               <a:spcAft>
-                <a:spcPts val="800"/>
+                <a:spcPts val="600"/>
               </a:spcAft>
-              <a:defRPr sz="1900"/>
-            </a:pPr>
-            <a:r>
-              <a:t>Quality flags so consumers know what is missing.</a:t>
+              <a:defRPr sz="1700"/>
+            </a:pPr>
+            <a:r>
+              <a:t>github.com/Sneha-8/IMT-542/tree/main/final</a:t>
             </a:r>
           </a:p>
           <a:p>
             <a:pPr>
               <a:spcAft>
-                <a:spcPts val="800"/>
+                <a:spcPts val="600"/>
               </a:spcAft>
-              <a:defRPr sz="1900"/>
-            </a:pPr>
-            <a:r>
-              <a:t>Public listings hide owner email/phone unless Bearer token authorizes access.</a:t>
-            </a:r>
-          </a:p>
-        </p:txBody>
-      </p:sp>
-    </p:spTree>
-  </p:cSld>
-  <p:clrMapOvr>
-    <a:masterClrMapping/>
-  </p:clrMapOvr>
-</p:sld>
-</file>
-
-<file path=ppt/slides/slide9.xml><?xml version="1.0" encoding="utf-8"?>
-<p:sld xmlns:a="http://schemas.openxmlformats.org/drawingml/2006/main" xmlns:p="http://schemas.openxmlformats.org/presentationml/2006/main" xmlns:r="http://schemas.openxmlformats.org/officeDocument/2006/relationships">
-  <p:cSld>
-    <p:spTree>
-      <p:nvGrpSpPr>
-        <p:cNvPr id="1" name=""/>
-        <p:cNvGrpSpPr/>
-        <p:nvPr/>
-      </p:nvGrpSpPr>
-      <p:grpSpPr/>
-      <p:sp>
-        <p:nvSpPr>
-          <p:cNvPr id="2" name="TextBox 1"/>
-          <p:cNvSpPr txBox="1"/>
-          <p:nvPr/>
-        </p:nvSpPr>
-        <p:spPr>
-          <a:xfrm>
-            <a:off x="457200" y="320040"/>
-            <a:ext cx="8229600" cy="914400"/>
-          </a:xfrm>
-          <a:prstGeom prst="rect">
-            <a:avLst/>
-          </a:prstGeom>
-          <a:noFill/>
-        </p:spPr>
-        <p:txBody>
-          <a:bodyPr wrap="none">
-            <a:spAutoFit/>
-          </a:bodyPr>
-          <a:lstStyle/>
-          <a:p>
-            <a:pPr>
-              <a:defRPr sz="3200" b="1">
-                <a:solidFill>
-                  <a:srgbClr val="4B2E83"/>
-                </a:solidFill>
-              </a:defRPr>
-            </a:pPr>
-            <a:r>
-              <a:t>How we got here</a:t>
-            </a:r>
-          </a:p>
-        </p:txBody>
-      </p:sp>
-      <p:sp>
-        <p:nvSpPr>
-          <p:cNvPr id="3" name="TextBox 2"/>
-          <p:cNvSpPr txBox="1"/>
-          <p:nvPr/>
-        </p:nvSpPr>
-        <p:spPr>
-          <a:xfrm>
-            <a:off x="457200" y="1280160"/>
-            <a:ext cx="8229600" cy="4846320"/>
-          </a:xfrm>
-          <a:prstGeom prst="rect">
-            <a:avLst/>
-          </a:prstGeom>
-          <a:noFill/>
-        </p:spPr>
-        <p:txBody>
-          <a:bodyPr wrap="square">
-            <a:spAutoFit/>
-          </a:bodyPr>
-          <a:lstStyle/>
-          <a:p>
-            <a:pPr>
-              <a:spcAft>
-                <a:spcPts val="800"/>
-              </a:spcAft>
-              <a:defRPr sz="1900"/>
-            </a:pPr>
-            <a:r>
-              <a:t>Started with Flask + JSON file.</a:t>
-            </a:r>
-          </a:p>
-          <a:p>
-            <a:pPr>
-              <a:spcAft>
-                <a:spcPts val="800"/>
-              </a:spcAft>
-              <a:defRPr sz="1900"/>
-            </a:pPr>
-            <a:r>
-              <a:t>Added MongoDB and aggregation endpoints.</a:t>
-            </a:r>
-          </a:p>
-          <a:p>
-            <a:pPr>
-              <a:spcAft>
-                <a:spcPts val="800"/>
-              </a:spcAft>
-              <a:defRPr sz="1900"/>
-            </a:pPr>
-            <a:r>
-              <a:t>Shipped schema v1.0, normalizer, tests, and this UI prototype.</a:t>
-            </a:r>
-          </a:p>
-          <a:p>
-            <a:pPr>
-              <a:spcAft>
-                <a:spcPts val="800"/>
-              </a:spcAft>
-              <a:defRPr sz="1900"/>
-            </a:pPr>
-          </a:p>
-          <a:p>
-            <a:pPr>
-              <a:spcAft>
-                <a:spcPts val="800"/>
-              </a:spcAft>
-              <a:defRPr sz="1900"/>
-            </a:pPr>
-            <a:r>
-              <a:t>Production path: Yelp Fusion feeds the same normalizer.</a:t>
+              <a:defRPr sz="1700"/>
+            </a:pPr>
+            <a:r>
+              <a:t>Questions?</a:t>
             </a:r>
           </a:p>
         </p:txBody>

</xml_diff>